<commit_message>
Agregar enlaces del repositorio y los reportes en las portadas
Canvas recibe la presentación como archivo: así los enlaces quedan a la vista.

Co-Authored-By: Claude Opus 5.5 <noreply@anthropic.com>
</commit_message>
<xml_diff>
--- a/docs/Entrega1_G4_API.pptx
+++ b/docs/Entrega1_G4_API.pptx
@@ -112,7 +112,7 @@
   <p:extLst>
     <p:ext uri="{521415D9-36F7-43E2-AB2F-B90AF26B5E84}">
       <p14:sectionLst xmlns:p14="http://schemas.microsoft.com/office/powerpoint/2010/main">
-        <p14:section name="Entrega 1" id="{3f2af020-2ba8-cef9-908e-3b1242f9b600}">
+        <p14:section name="Entrega 1" id="{165fb8c9-2b15-a2d7-4115-f220f35333f2}">
           <p14:sldIdLst>
             <p14:sldId id="256"/>
             <p14:sldId id="257"/>
@@ -1754,6 +1754,136 @@
           </a:p>
         </p:txBody>
       </p:sp>
+      <p:sp>
+        <p:nvSpPr>
+          <p:cNvPr id="4" name="Enlace Repositorio"/>
+          <p:cNvSpPr/>
+          <p:nvPr/>
+        </p:nvSpPr>
+        <p:spPr>
+          <a:xfrm>
+            <a:off x="731520" y="5257800"/>
+            <a:ext cx="2743200" cy="384048"/>
+          </a:xfrm>
+          <a:prstGeom prst="roundRect">
+            <a:avLst>
+              <a:gd name="adj" fmla="val 19048"/>
+            </a:avLst>
+          </a:prstGeom>
+          <a:solidFill>
+            <a:schemeClr val="bg1"/>
+          </a:solidFill>
+          <a:ln/>
+        </p:spPr>
+      </p:sp>
+      <p:sp>
+        <p:nvSpPr>
+          <p:cNvPr id="5" name="Text 3"/>
+          <p:cNvSpPr txBox="1"/>
+          <p:nvPr/>
+        </p:nvSpPr>
+        <p:spPr>
+          <a:xfrm>
+            <a:off x="731520" y="5257800"/>
+            <a:ext cx="2743200" cy="384048"/>
+          </a:xfrm>
+          <a:prstGeom prst="rect">
+            <a:avLst/>
+          </a:prstGeom>
+          <a:noFill/>
+          <a:ln/>
+        </p:spPr>
+        <p:txBody>
+          <a:bodyPr wrap="square" lIns="0" tIns="0" rIns="0" bIns="0" rtlCol="0" anchor="ctr"/>
+          <a:lstStyle/>
+          <a:p>
+            <a:pPr algn="ctr" indent="0" marL="0">
+              <a:buNone/>
+            </a:pPr>
+            <a:r>
+              <a:rPr lang="en-US" sz="1300" b="1" u="sng" dirty="0">
+                <a:solidFill>
+                  <a:schemeClr val="accent1"/>
+                </a:solidFill>
+                <a:hlinkClick r:id="rId1" invalidUrl="" action="" tgtFrame="" tooltip="Repositorio" history="1" highlightClick="0" endSnd="0">
+                  <a:extLst>
+                    <a:ext uri="{A12FA001-AC4F-418D-AE19-62706E023703}">
+                      <ahyp:hlinkClr xmlns:ahyp="http://schemas.microsoft.com/office/drawing/2018/hyperlinkcolor" val="tx"/>
+                    </a:ext>
+                  </a:extLst>
+                </a:hlinkClick>
+              </a:rPr>
+              <a:t>github.com/Joharjbe/qolqe-wallet</a:t>
+            </a:r>
+            <a:endParaRPr lang="en-US" sz="1300" dirty="0"/>
+          </a:p>
+        </p:txBody>
+      </p:sp>
+      <p:sp>
+        <p:nvSpPr>
+          <p:cNvPr id="6" name="Enlace Reportes"/>
+          <p:cNvSpPr/>
+          <p:nvPr/>
+        </p:nvSpPr>
+        <p:spPr>
+          <a:xfrm>
+            <a:off x="3611880" y="5257800"/>
+            <a:ext cx="2743200" cy="384048"/>
+          </a:xfrm>
+          <a:prstGeom prst="roundRect">
+            <a:avLst>
+              <a:gd name="adj" fmla="val 19048"/>
+            </a:avLst>
+          </a:prstGeom>
+          <a:solidFill>
+            <a:schemeClr val="bg1"/>
+          </a:solidFill>
+          <a:ln/>
+        </p:spPr>
+      </p:sp>
+      <p:sp>
+        <p:nvSpPr>
+          <p:cNvPr id="7" name="Text 5"/>
+          <p:cNvSpPr txBox="1"/>
+          <p:nvPr/>
+        </p:nvSpPr>
+        <p:spPr>
+          <a:xfrm>
+            <a:off x="3611880" y="5257800"/>
+            <a:ext cx="2743200" cy="384048"/>
+          </a:xfrm>
+          <a:prstGeom prst="rect">
+            <a:avLst/>
+          </a:prstGeom>
+          <a:noFill/>
+          <a:ln/>
+        </p:spPr>
+        <p:txBody>
+          <a:bodyPr wrap="square" lIns="0" tIns="0" rIns="0" bIns="0" rtlCol="0" anchor="ctr"/>
+          <a:lstStyle/>
+          <a:p>
+            <a:pPr algn="ctr" indent="0" marL="0">
+              <a:buNone/>
+            </a:pPr>
+            <a:r>
+              <a:rPr lang="en-US" sz="1300" b="1" u="sng" dirty="0">
+                <a:solidFill>
+                  <a:schemeClr val="accent1"/>
+                </a:solidFill>
+                <a:hlinkClick r:id="rId2" invalidUrl="" action="" tgtFrame="" tooltip="Reportes" history="1" highlightClick="0" endSnd="0">
+                  <a:extLst>
+                    <a:ext uri="{A12FA001-AC4F-418D-AE19-62706E023703}">
+                      <ahyp:hlinkClr xmlns:ahyp="http://schemas.microsoft.com/office/drawing/2018/hyperlinkcolor" val="tx"/>
+                    </a:ext>
+                  </a:extLst>
+                </a:hlinkClick>
+              </a:rPr>
+              <a:t>joharjbe.github.io/qolqe-wallet</a:t>
+            </a:r>
+            <a:endParaRPr lang="en-US" sz="1300" dirty="0"/>
+          </a:p>
+        </p:txBody>
+      </p:sp>
     </p:spTree>
   </p:cSld>
   <p:clrMapOvr>

</xml_diff>